<commit_message>
updated Readme and added new images
</commit_message>
<xml_diff>
--- a/exercises/TM265 - SAP Joule for Consultants- Unified knowledge for requirements and designs.pptx
+++ b/exercises/TM265 - SAP Joule for Consultants- Unified knowledge for requirements and designs.pptx
@@ -202,7 +202,7 @@
           <a:p>
             <a:fld id="{281ED482-9723-E54C-957D-2EFEE26455D5}" type="datetimeFigureOut">
               <a:rPr lang="en-US" smtClean="0"/>
-              <a:t>10/24/26</a:t>
+              <a:t>10/26/26</a:t>
             </a:fld>
             <a:endParaRPr lang="en-US"/>
           </a:p>
@@ -711,7 +711,7 @@
           <a:p>
             <a:fld id="{92E5461F-EC62-5147-B8AE-4CEA5377BB3A}" type="datetimeFigureOut">
               <a:rPr lang="en-US" smtClean="0"/>
-              <a:t>10/24/26</a:t>
+              <a:t>10/26/26</a:t>
             </a:fld>
             <a:endParaRPr lang="en-US"/>
           </a:p>
@@ -911,7 +911,7 @@
           <a:p>
             <a:fld id="{92E5461F-EC62-5147-B8AE-4CEA5377BB3A}" type="datetimeFigureOut">
               <a:rPr lang="en-US" smtClean="0"/>
-              <a:t>10/24/26</a:t>
+              <a:t>10/26/26</a:t>
             </a:fld>
             <a:endParaRPr lang="en-US"/>
           </a:p>
@@ -1121,7 +1121,7 @@
           <a:p>
             <a:fld id="{92E5461F-EC62-5147-B8AE-4CEA5377BB3A}" type="datetimeFigureOut">
               <a:rPr lang="en-US" smtClean="0"/>
-              <a:t>10/24/26</a:t>
+              <a:t>10/26/26</a:t>
             </a:fld>
             <a:endParaRPr lang="en-US"/>
           </a:p>
@@ -2109,7 +2109,7 @@
           <a:p>
             <a:fld id="{92E5461F-EC62-5147-B8AE-4CEA5377BB3A}" type="datetimeFigureOut">
               <a:rPr lang="en-US" smtClean="0"/>
-              <a:t>10/24/26</a:t>
+              <a:t>10/26/26</a:t>
             </a:fld>
             <a:endParaRPr lang="en-US"/>
           </a:p>
@@ -2385,7 +2385,7 @@
           <a:p>
             <a:fld id="{92E5461F-EC62-5147-B8AE-4CEA5377BB3A}" type="datetimeFigureOut">
               <a:rPr lang="en-US" smtClean="0"/>
-              <a:t>10/24/26</a:t>
+              <a:t>10/26/26</a:t>
             </a:fld>
             <a:endParaRPr lang="en-US"/>
           </a:p>
@@ -2653,7 +2653,7 @@
           <a:p>
             <a:fld id="{92E5461F-EC62-5147-B8AE-4CEA5377BB3A}" type="datetimeFigureOut">
               <a:rPr lang="en-US" smtClean="0"/>
-              <a:t>10/24/26</a:t>
+              <a:t>10/26/26</a:t>
             </a:fld>
             <a:endParaRPr lang="en-US"/>
           </a:p>
@@ -3068,7 +3068,7 @@
           <a:p>
             <a:fld id="{92E5461F-EC62-5147-B8AE-4CEA5377BB3A}" type="datetimeFigureOut">
               <a:rPr lang="en-US" smtClean="0"/>
-              <a:t>10/24/26</a:t>
+              <a:t>10/26/26</a:t>
             </a:fld>
             <a:endParaRPr lang="en-US"/>
           </a:p>
@@ -3210,7 +3210,7 @@
           <a:p>
             <a:fld id="{92E5461F-EC62-5147-B8AE-4CEA5377BB3A}" type="datetimeFigureOut">
               <a:rPr lang="en-US" smtClean="0"/>
-              <a:t>10/24/26</a:t>
+              <a:t>10/26/26</a:t>
             </a:fld>
             <a:endParaRPr lang="en-US"/>
           </a:p>
@@ -3323,7 +3323,7 @@
           <a:p>
             <a:fld id="{92E5461F-EC62-5147-B8AE-4CEA5377BB3A}" type="datetimeFigureOut">
               <a:rPr lang="en-US" smtClean="0"/>
-              <a:t>10/24/26</a:t>
+              <a:t>10/26/26</a:t>
             </a:fld>
             <a:endParaRPr lang="en-US"/>
           </a:p>
@@ -3636,7 +3636,7 @@
           <a:p>
             <a:fld id="{92E5461F-EC62-5147-B8AE-4CEA5377BB3A}" type="datetimeFigureOut">
               <a:rPr lang="en-US" smtClean="0"/>
-              <a:t>10/24/26</a:t>
+              <a:t>10/26/26</a:t>
             </a:fld>
             <a:endParaRPr lang="en-US"/>
           </a:p>
@@ -3925,7 +3925,7 @@
           <a:p>
             <a:fld id="{92E5461F-EC62-5147-B8AE-4CEA5377BB3A}" type="datetimeFigureOut">
               <a:rPr lang="en-US" smtClean="0"/>
-              <a:t>10/24/26</a:t>
+              <a:t>10/26/26</a:t>
             </a:fld>
             <a:endParaRPr lang="en-US"/>
           </a:p>
@@ -4168,7 +4168,7 @@
           <a:p>
             <a:fld id="{92E5461F-EC62-5147-B8AE-4CEA5377BB3A}" type="datetimeFigureOut">
               <a:rPr lang="en-US" smtClean="0"/>
-              <a:t>10/24/26</a:t>
+              <a:t>10/26/26</a:t>
             </a:fld>
             <a:endParaRPr lang="en-US"/>
           </a:p>
@@ -4973,7 +4973,7 @@
         </p:nvSpPr>
         <p:spPr>
           <a:xfrm>
-            <a:off x="1439625" y="2922266"/>
+            <a:off x="1439624" y="3931250"/>
             <a:ext cx="6435499" cy="307648"/>
           </a:xfrm>
           <a:prstGeom prst="rect">
@@ -5060,57 +5060,6 @@
                 <a:cs typeface="72 Brand" pitchFamily="34" charset="-128"/>
               </a:rPr>
               <a:t>03</a:t>
-            </a:r>
-          </a:p>
-        </p:txBody>
-      </p:sp>
-      <p:sp>
-        <p:nvSpPr>
-          <p:cNvPr id="23" name="TextBox 50">
-            <a:extLst>
-              <a:ext uri="{FF2B5EF4-FFF2-40B4-BE49-F238E27FC236}">
-                <a16:creationId xmlns:a16="http://schemas.microsoft.com/office/drawing/2014/main" id="{7F3200D2-2769-41F7-D35F-BB457E4E0CD7}"/>
-              </a:ext>
-            </a:extLst>
-          </p:cNvPr>
-          <p:cNvSpPr txBox="1"/>
-          <p:nvPr/>
-        </p:nvSpPr>
-        <p:spPr>
-          <a:xfrm>
-            <a:off x="1439625" y="3931249"/>
-            <a:ext cx="6435499" cy="307648"/>
-          </a:xfrm>
-          <a:prstGeom prst="rect">
-            <a:avLst/>
-          </a:prstGeom>
-          <a:noFill/>
-        </p:spPr>
-        <p:txBody>
-          <a:bodyPr wrap="square" lIns="0" tIns="0" rIns="0" bIns="0" rtlCol="0" anchor="ctr" anchorCtr="0">
-            <a:spAutoFit/>
-          </a:bodyPr>
-          <a:lstStyle/>
-          <a:p>
-            <a:pPr fontAlgn="base">
-              <a:spcBef>
-                <a:spcPts val="400"/>
-              </a:spcBef>
-              <a:spcAft>
-                <a:spcPct val="0"/>
-              </a:spcAft>
-              <a:buClr>
-                <a:schemeClr val="tx1"/>
-              </a:buClr>
-              <a:buSzPct val="100000"/>
-            </a:pPr>
-            <a:r>
-              <a:rPr lang="en-US" sz="1999" kern="0" noProof="1">
-                <a:latin typeface="72 Brand Medium" panose="020B0604030603020204" pitchFamily="34" charset="0"/>
-                <a:ea typeface="72 Brand" pitchFamily="34" charset="-128"/>
-                <a:cs typeface="72 Brand" pitchFamily="34" charset="-128"/>
-              </a:rPr>
-              <a:t>OOX</a:t>
             </a:r>
           </a:p>
         </p:txBody>
@@ -5227,6 +5176,62 @@
           </a:fontRef>
         </p:style>
       </p:cxnSp>
+      <p:sp>
+        <p:nvSpPr>
+          <p:cNvPr id="2" name="TextBox 46">
+            <a:extLst>
+              <a:ext uri="{FF2B5EF4-FFF2-40B4-BE49-F238E27FC236}">
+                <a16:creationId xmlns:a16="http://schemas.microsoft.com/office/drawing/2014/main" id="{E7F0F22F-7CCB-9A3C-DB5D-E718CB223769}"/>
+              </a:ext>
+            </a:extLst>
+          </p:cNvPr>
+          <p:cNvSpPr txBox="1"/>
+          <p:nvPr/>
+        </p:nvSpPr>
+        <p:spPr>
+          <a:xfrm>
+            <a:off x="1439624" y="2922202"/>
+            <a:ext cx="6435499" cy="307777"/>
+          </a:xfrm>
+          <a:prstGeom prst="rect">
+            <a:avLst/>
+          </a:prstGeom>
+          <a:noFill/>
+        </p:spPr>
+        <p:txBody>
+          <a:bodyPr wrap="square" lIns="0" tIns="0" rIns="0" bIns="0" rtlCol="0" anchor="ctr" anchorCtr="0">
+            <a:spAutoFit/>
+          </a:bodyPr>
+          <a:lstStyle>
+            <a:defPPr>
+              <a:defRPr lang="en-DE"/>
+            </a:defPPr>
+            <a:lvl1pPr fontAlgn="base">
+              <a:spcBef>
+                <a:spcPts val="400"/>
+              </a:spcBef>
+              <a:spcAft>
+                <a:spcPct val="0"/>
+              </a:spcAft>
+              <a:buClr>
+                <a:schemeClr val="tx1"/>
+              </a:buClr>
+              <a:buSzPct val="100000"/>
+              <a:defRPr sz="1999" kern="0">
+                <a:latin typeface="72 Brand Medium" panose="020B0604030603020204" pitchFamily="34" charset="0"/>
+                <a:ea typeface="72 Brand" pitchFamily="34" charset="-128"/>
+                <a:cs typeface="72 Brand" pitchFamily="34" charset="-128"/>
+              </a:defRPr>
+            </a:lvl1pPr>
+          </a:lstStyle>
+          <a:p>
+            <a:r>
+              <a:rPr lang="en-SG" dirty="0"/>
+              <a:t>Three Ways to Make J4C Personal</a:t>
+            </a:r>
+          </a:p>
+        </p:txBody>
+      </p:sp>
     </p:spTree>
     <p:extLst>
       <p:ext uri="{BB962C8B-B14F-4D97-AF65-F5344CB8AC3E}">
@@ -12913,7 +12918,15 @@
 </file>
 
 <file path=customXml/item1.xml><?xml version="1.0" encoding="utf-8"?>
-<TemplafySlideTemplateConfiguration><![CDATA[{"slideVersion":3,"isValidatorEnabled":false,"isLocked":false,"elementsMetadata":[],"slideId":"1328131217384275976","enableDocumentContentUpdater":false,"version":"2.0"}]]></TemplafySlideTemplateConfiguration>
+<p:properties xmlns:p="http://schemas.microsoft.com/office/2006/metadata/properties" xmlns:xsi="http://www.w3.org/2001/XMLSchema-instance" xmlns:pc="http://schemas.microsoft.com/office/infopath/2007/PartnerControls">
+  <documentManagement>
+    <lcf76f155ced4ddcb4097134ff3c332f xmlns="ec8b813e-ded4-4f1f-a63f-6b0325eea3cf">
+      <Terms xmlns="http://schemas.microsoft.com/office/infopath/2007/PartnerControls"/>
+    </lcf76f155ced4ddcb4097134ff3c332f>
+    <TaxCatchAll xmlns="ad97e172-310b-42bf-9229-ea2dcd9b468b" xsi:nil="true"/>
+    <TechnicalDocumentRAGeService_x0028_DataPipeline_x0029_ xmlns="ec8b813e-ded4-4f1f-a63f-6b0325eea3cf">https://sapnam-my.sharepoint.com/:w:/g/personal/sagar_sharma05_sap_com/EfNpRDyIQolKjp4WiMvdmBsBkcfEmG6b_tB2zSiAOM3fKA?e=r056Bg</TechnicalDocumentRAGeService_x0028_DataPipeline_x0029_>
+  </documentManagement>
+</p:properties>
 </file>
 
 <file path=customXml/item2.xml><?xml version="1.0" encoding="utf-8"?>
@@ -12926,22 +12939,10 @@
 </file>
 
 <file path=customXml/item3.xml><?xml version="1.0" encoding="utf-8"?>
-<p:properties xmlns:p="http://schemas.microsoft.com/office/2006/metadata/properties" xmlns:xsi="http://www.w3.org/2001/XMLSchema-instance" xmlns:pc="http://schemas.microsoft.com/office/infopath/2007/PartnerControls">
-  <documentManagement>
-    <lcf76f155ced4ddcb4097134ff3c332f xmlns="ec8b813e-ded4-4f1f-a63f-6b0325eea3cf">
-      <Terms xmlns="http://schemas.microsoft.com/office/infopath/2007/PartnerControls"/>
-    </lcf76f155ced4ddcb4097134ff3c332f>
-    <TaxCatchAll xmlns="ad97e172-310b-42bf-9229-ea2dcd9b468b" xsi:nil="true"/>
-    <TechnicalDocumentRAGeService_x0028_DataPipeline_x0029_ xmlns="ec8b813e-ded4-4f1f-a63f-6b0325eea3cf">https://sapnam-my.sharepoint.com/:w:/g/personal/sagar_sharma05_sap_com/EfNpRDyIQolKjp4WiMvdmBsBkcfEmG6b_tB2zSiAOM3fKA?e=r056Bg</TechnicalDocumentRAGeService_x0028_DataPipeline_x0029_>
-  </documentManagement>
-</p:properties>
+<TemplafySlideTemplateConfiguration><![CDATA[{"slideVersion":3,"isValidatorEnabled":false,"isLocked":false,"elementsMetadata":[],"slideId":"1328131217384275976","enableDocumentContentUpdater":false,"version":"2.0"}]]></TemplafySlideTemplateConfiguration>
 </file>
 
 <file path=customXml/item4.xml><?xml version="1.0" encoding="utf-8"?>
-<TemplafySlideFormConfiguration><![CDATA[{"formFields":[],"formDataEntries":[]}]]></TemplafySlideFormConfiguration>
-</file>
-
-<file path=customXml/item5.xml><?xml version="1.0" encoding="utf-8"?>
 <ct:contentTypeSchema xmlns:ct="http://schemas.microsoft.com/office/2006/metadata/contentType" xmlns:ma="http://schemas.microsoft.com/office/2006/metadata/properties/metaAttributes" ct:_="" ma:_="" ma:contentTypeName="Document" ma:contentTypeID="0x010100899F4FC9C81ED845AD94FC75EBAEEC57" ma:contentTypeVersion="17" ma:contentTypeDescription="Create a new document." ma:contentTypeScope="" ma:versionID="47e0007633e2a69f5709829093753984">
   <xsd:schema xmlns:xsd="http://www.w3.org/2001/XMLSchema" xmlns:xs="http://www.w3.org/2001/XMLSchema" xmlns:p="http://schemas.microsoft.com/office/2006/metadata/properties" xmlns:ns2="ec8b813e-ded4-4f1f-a63f-6b0325eea3cf" xmlns:ns3="ad97e172-310b-42bf-9229-ea2dcd9b468b" targetNamespace="http://schemas.microsoft.com/office/2006/metadata/properties" ma:root="true" ma:fieldsID="1f67a4738217f1cc983b785320136ab3" ns2:_="" ns3:_="">
     <xsd:import namespace="ec8b813e-ded4-4f1f-a63f-6b0325eea3cf"/>
@@ -13190,21 +13191,11 @@
 </ct:contentTypeSchema>
 </file>
 
-<file path=customXml/itemProps1.xml><?xml version="1.0" encoding="utf-8"?>
-<ds:datastoreItem xmlns:ds="http://schemas.openxmlformats.org/officeDocument/2006/customXml" ds:itemID="{FCDADE86-33AC-F045-834E-85ABB4AF5E91}">
-  <ds:schemaRefs/>
-</ds:datastoreItem>
+<file path=customXml/item5.xml><?xml version="1.0" encoding="utf-8"?>
+<TemplafySlideFormConfiguration><![CDATA[{"formFields":[],"formDataEntries":[]}]]></TemplafySlideFormConfiguration>
 </file>
 
-<file path=customXml/itemProps2.xml><?xml version="1.0" encoding="utf-8"?>
-<ds:datastoreItem xmlns:ds="http://schemas.openxmlformats.org/officeDocument/2006/customXml" ds:itemID="{9F3C7D37-D5B1-4A40-AFCD-2771D394621C}">
-  <ds:schemaRefs>
-    <ds:schemaRef ds:uri="http://schemas.microsoft.com/sharepoint/v3/contenttype/forms"/>
-  </ds:schemaRefs>
-</ds:datastoreItem>
-</file>
-
-<file path=customXml/itemProps3.xml><?xml version="1.0" encoding="utf-8"?>
+<file path=customXml/itemProps1.xml><?xml version="1.0" encoding="utf-8"?>
 <ds:datastoreItem xmlns:ds="http://schemas.openxmlformats.org/officeDocument/2006/customXml" ds:itemID="{4F8AA36A-914D-43B4-880D-63610670267B}">
   <ds:schemaRefs>
     <ds:schemaRef ds:uri="http://schemas.openxmlformats.org/package/2006/metadata/core-properties"/>
@@ -13221,13 +13212,21 @@
 </ds:datastoreItem>
 </file>
 
-<file path=customXml/itemProps4.xml><?xml version="1.0" encoding="utf-8"?>
-<ds:datastoreItem xmlns:ds="http://schemas.openxmlformats.org/officeDocument/2006/customXml" ds:itemID="{1A5C0054-ED86-FF44-8598-F88C8909EB8E}">
+<file path=customXml/itemProps2.xml><?xml version="1.0" encoding="utf-8"?>
+<ds:datastoreItem xmlns:ds="http://schemas.openxmlformats.org/officeDocument/2006/customXml" ds:itemID="{9F3C7D37-D5B1-4A40-AFCD-2771D394621C}">
+  <ds:schemaRefs>
+    <ds:schemaRef ds:uri="http://schemas.microsoft.com/sharepoint/v3/contenttype/forms"/>
+  </ds:schemaRefs>
+</ds:datastoreItem>
+</file>
+
+<file path=customXml/itemProps3.xml><?xml version="1.0" encoding="utf-8"?>
+<ds:datastoreItem xmlns:ds="http://schemas.openxmlformats.org/officeDocument/2006/customXml" ds:itemID="{FCDADE86-33AC-F045-834E-85ABB4AF5E91}">
   <ds:schemaRefs/>
 </ds:datastoreItem>
 </file>
 
-<file path=customXml/itemProps5.xml><?xml version="1.0" encoding="utf-8"?>
+<file path=customXml/itemProps4.xml><?xml version="1.0" encoding="utf-8"?>
 <ds:datastoreItem xmlns:ds="http://schemas.openxmlformats.org/officeDocument/2006/customXml" ds:itemID="{03415605-5A6E-478C-829B-313D07257331}">
   <ds:schemaRefs>
     <ds:schemaRef ds:uri="ad97e172-310b-42bf-9229-ea2dcd9b468b"/>
@@ -13246,6 +13245,12 @@
 </ds:datastoreItem>
 </file>
 
+<file path=customXml/itemProps5.xml><?xml version="1.0" encoding="utf-8"?>
+<ds:datastoreItem xmlns:ds="http://schemas.openxmlformats.org/officeDocument/2006/customXml" ds:itemID="{1A5C0054-ED86-FF44-8598-F88C8909EB8E}">
+  <ds:schemaRefs/>
+</ds:datastoreItem>
+</file>
+
 <file path=docMetadata/LabelInfo.xml><?xml version="1.0" encoding="utf-8"?>
 <clbl:labelList xmlns:clbl="http://schemas.microsoft.com/office/2020/mipLabelMetadata">
   <clbl:label id="{0cf7ac0a-4681-4823-ab0b-04ef02c5f873}" enabled="1" method="Standard" siteId="{42f7676c-f455-423c-82f6-dc2d99791af7}" removed="0"/>

</xml_diff>